<commit_message>
Adopt author's IDE edits: letter opening clarifies color-only markup and double-anonymization; sync demo pptx and 0903 letter snapshot
</commit_message>
<xml_diff>
--- a/final/submission_package_CAG/TCAS_Demo_fixed.pptx
+++ b/final/submission_package_CAG/TCAS_Demo_fixed.pptx
@@ -4412,7 +4412,7 @@
                 <a:ea typeface="+mj-ea"/>
                 <a:cs typeface="Times New Roman" panose="02020603050405020304" charset="0"/>
               </a:rPr>
-              <a:t>Large-scale validation on 300 objects</a:t>
+              <a:t>Large-scale pooled evaluation on 300 objects</a:t>
             </a:r>
           </a:p>
         </p:txBody>
@@ -4928,6 +4928,16 @@
                 <a:cs typeface="Times New Roman" panose="02020603050405020304" charset="0"/>
               </a:rPr>
               <a:t>Thank you for watching!</a:t>
+            </a:r>
+          </a:p>
+          <a:p>
+            <a:pPr algn="ctr"/>
+            <a:r>
+              <a:rPr lang="en-US" altLang="zh-CN" sz="4400">
+                <a:latin typeface="Times New Roman" panose="02020603050405020304" charset="0"/>
+                <a:cs typeface="Times New Roman" panose="02020603050405020304" charset="0"/>
+              </a:rPr>
+              <a:t>Checkpoints and evaluation code are available upon reasonable request.</a:t>
             </a:r>
           </a:p>
         </p:txBody>
@@ -5177,7 +5187,7 @@
       </p:nvGrpSpPr>
       <p:grpSpPr>
         <a:xfrm>
-          <a:off x="0" y="0"/>
+          <a:off x="0" y="3429000"/>
           <a:ext cx="0" cy="0"/>
           <a:chOff x="0" y="0"/>
           <a:chExt cx="0" cy="0"/>

</xml_diff>